<commit_message>
docs(ppt): 重生成答辩 PPT（1336 / 49 事件 / 81 测试文件）
</commit_message>
<xml_diff>
--- a/docs/交付/答辩PPT.pptx
+++ b/docs/交付/答辩PPT.pptx
@@ -4887,7 +4887,7 @@
                 <a:latin typeface="微软雅黑"/>
                 <a:ea typeface="微软雅黑"/>
               </a:rPr>
-              <a:t>– 自动化测试：1330 passed / 4 skipped（2026-10-24 终测）</a:t>
+              <a:t>– 自动化测试：1336 passed / 4 skipped（2026-10-24 终测）</a:t>
             </a:r>
           </a:p>
           <a:p>
@@ -5137,7 +5137,7 @@
                 <a:latin typeface="微软雅黑"/>
                 <a:ea typeface="微软雅黑"/>
               </a:rPr>
-              <a:t>出处：上列模块与脚本均为仓库内可复核数字；红队 runner 为 commit c94a8cd 交付的四模块；测试条数取自 2026-10-24 终测（1330 passed / 4 skipped；上一轮 1152，最早基线 1131），红队通过数为 2026-10-24 复跑（43 / 0），A/B 两轮见 tests/eval/evaluation_report.md §11（r1 20261024T134524 / r2 20261024T135754），历史归因见 docs/红队失败归因.md。</a:t>
+              <a:t>出处：上列模块与脚本均为仓库内可复核数字；红队 runner 为 commit c94a8cd 交付的四模块；测试条数取自 2026-10-24 终测（1336 passed / 4 skipped；上一轮 1152，最早基线 1131），红队通过数为 2026-10-24 复跑（43 / 0），A/B 两轮见 tests/eval/evaluation_report.md §11（r1 20261024T134524 / r2 20261024T135754），历史归因见 docs/红队失败归因.md。</a:t>
             </a:r>
           </a:p>
         </p:txBody>

</xml_diff>

<commit_message>
docs(manifest): 数字收口到 1468/41/31 表/62 事件，清单以 HEAD 59e6cf4 重生成
- release_manifest.json: head 59e6cf4、pytest 1468/0/4/61.53s、tables 31、events 62、paths 41、tests 91
- 以表格与清单为权威，批量对齐 README/docs 的 表 30→31、事件 61→62、日期与出数时点
- docs/03 补 subscription_verdicts 字段与约束；docs/10 补生日补验证/同名消歧/订阅定性三条必测点
- PPT 与大纲数字同步（12 页、1468、62 类事件），PROGRESS 记 v2.3.0
</commit_message>
<xml_diff>
--- a/docs/交付/答辩PPT.pptx
+++ b/docs/交付/答辩PPT.pptx
@@ -5988,7 +5988,7 @@
                 <a:latin typeface="微软雅黑"/>
                 <a:ea typeface="微软雅黑"/>
               </a:rPr>
-              <a:t>▪ 指标：35 工具 ｜ 13 规则 ｜ 30 表 ｜ 61 审计事件 ｜ 41 路由 ｜ 6 场景 ｜ 1468 测试 ｜ 43 红队 ｜ 7 旅程</a:t>
+              <a:t>▪ 指标：35 工具 ｜ 13 规则 ｜ 30 表 ｜ 62 审计事件 ｜ 41 路由 ｜ 6 场景 ｜ 1468 测试 ｜ 43 红队 ｜ 7 旅程</a:t>
             </a:r>
           </a:p>
           <a:p>
@@ -11660,7 +11660,7 @@
                 <a:latin typeface="微软雅黑"/>
                 <a:ea typeface="微软雅黑"/>
               </a:rPr>
-              <a:t>– 61 类事件闭集：写不进白名单的名字会被拒绝</a:t>
+              <a:t>– 62 类事件闭集：写不进白名单的名字会被拒绝</a:t>
             </a:r>
           </a:p>
         </p:txBody>
@@ -11857,7 +11857,7 @@
                 <a:latin typeface="微软雅黑"/>
                 <a:ea typeface="微软雅黑"/>
               </a:rPr>
-              <a:t>出处：app/audit.py（哈希链与只增不改触发器）；tests/test_audit.py；61 类见 EVENT_TYPES。</a:t>
+              <a:t>出处：app/audit.py（哈希链与只增不改触发器）；tests/test_audit.py；62 类见 EVENT_TYPES。</a:t>
             </a:r>
           </a:p>
         </p:txBody>

</xml_diff>